<commit_message>
refactor: read Datadash over its typed REST API; fix review findings
- Replace the MCP client with the REST API, typed from the pinned OpenAPI
  spec (openapi/, src/generated/). Linked user, token, market and event come
  filled in on each row, so a round needs 3 calls instead of 5.
- Retries for timeouts, network errors, 429 and 5xx; clearer errors.
- State lock without race windows; stale, own-pid and recycled-pid locks
  are taken over.
- "Valid for" counts down in minutes in the last hour, so late subscribers
  and retries get the whole window.
- Missing ids raise instead of silently becoming NaN; the backtest skips and
  counts incomplete rows and only replays YES/NO outcomes, like live.
- Track record reuses settled outcomes and tolerates single failed lookups.

Co-Authored-By: Arijit <arijitad.uae@gmail.com>
</commit_message>
<xml_diff>
--- a/pitch/Datadash-Smart-Money.pptx
+++ b/pitch/Datadash-Smart-Money.pptx
@@ -1041,7 +1041,7 @@
           <a:p>
             <a:r>
               <a:rPr lang="en-US" dirty="0"/>
-              <a:t>A real signal from pnpm preview on 2026-09-23. The last line shows what the subscriber's agent does next when copy-trading is on; in the demo we run it live.</a:t>
+              <a:t>A real signal from pnpm preview on 2026-09-23. The last line describes what the subscriber's agent does next when copy-trading is on; no order had been placed when this deck was made. In the demo we run it live.</a:t>
             </a:r>
             <a:endParaRPr lang="en-US" dirty="0"/>
           </a:p>
@@ -3087,7 +3087,7 @@
         <p:spPr>
           <a:xfrm>
             <a:off x="1371600" y="640080"/>
-            <a:ext cx="3657600" cy="502920"/>
+            <a:ext cx="5486400" cy="502920"/>
           </a:xfrm>
           <a:prstGeom prst="rect">
             <a:avLst/>
@@ -3111,7 +3111,7 @@
                 <a:ea typeface="Arial" pitchFamily="34" charset="-122"/>
                 <a:cs typeface="Arial" pitchFamily="34" charset="-120"/>
               </a:rPr>
-              <a:t>Datadash</a:t>
+              <a:t>Datadash Polymarket Analytics</a:t>
             </a:r>
             <a:endParaRPr lang="en-US" sz="2200" dirty="0"/>
           </a:p>
@@ -6841,7 +6841,7 @@
         <p:spPr>
           <a:xfrm>
             <a:off x="1371600" y="640080"/>
-            <a:ext cx="3657600" cy="502920"/>
+            <a:ext cx="5486400" cy="502920"/>
           </a:xfrm>
           <a:prstGeom prst="rect">
             <a:avLst/>
@@ -6865,7 +6865,7 @@
                 <a:ea typeface="Arial" pitchFamily="34" charset="-122"/>
                 <a:cs typeface="Arial" pitchFamily="34" charset="-120"/>
               </a:rPr>
-              <a:t>Datadash</a:t>
+              <a:t>Datadash Polymarket Analytics</a:t>
             </a:r>
             <a:endParaRPr lang="en-US" sz="2200" dirty="0"/>
           </a:p>
@@ -8953,7 +8953,7 @@
                 <a:ea typeface="Courier New" pitchFamily="34" charset="-122"/>
                 <a:cs typeface="Courier New" pitchFamily="34" charset="-120"/>
               </a:rPr>
-              <a:t>limit order: NO at 0.73, $5, via the Polymarket plugin</a:t>
+              <a:t>if copy-trading: limit order NO at 0.73 or less, your amount</a:t>
             </a:r>
             <a:endParaRPr lang="en-US" sz="1500" dirty="0"/>
           </a:p>

</xml_diff>

<commit_message>
feat: any high-scoring wallet can trigger; faster rounds; server setup
- A signal can start from any wallet among Datadash's 1,000 highest-scoring
  positions; the top-500 consensus now needs at least $10,000 on the side.
- Agreement is checked before freshness, so recent buys are only fetched for
  the survivors (a round went from about 149s to 23s with the same result).
- Recent buys are paged; ranks are shown only inside the top 500; cleaner
  trader names.
- deploy/setup-ubuntu.sh: one-shot setup for the DigitalOcean server.
- Backtest report re-run on the YES/NO-only rules.

Co-Authored-By: Arijit <arijitad.uae@gmail.com>
</commit_message>
<xml_diff>
--- a/pitch/Datadash-Smart-Money.pptx
+++ b/pitch/Datadash-Smart-Money.pptx
@@ -7909,7 +7909,7 @@
                 <a:ea typeface="Arial" pitchFamily="34" charset="-122"/>
                 <a:cs typeface="Arial" pitchFamily="34" charset="-120"/>
               </a:rPr>
-              <a:t>A top-500 trader holds 3x+ their usual size, with a high Datadash score. Gives the moment, the price and the size.</a:t>
+              <a:t>One of Datadash's 1,000 top-scoring positions, from any wallet, 3x+ its usual size. Gives the moment, the price and the size.</a:t>
             </a:r>
             <a:endParaRPr lang="en-US" sz="1500" dirty="0"/>
           </a:p>
@@ -8104,7 +8104,7 @@
                 <a:ea typeface="Arial" pitchFamily="34" charset="-122"/>
                 <a:cs typeface="Arial" pitchFamily="34" charset="-120"/>
               </a:rPr>
-              <a:t>60%+ of the money top-500 wallets hold on that market sits on the same side, across 3+ wallets.</a:t>
+              <a:t>The 500 most profitable traders put 60%+ of their money on the same side: $10K+, 3+ wallets.</a:t>
             </a:r>
             <a:endParaRPr lang="en-US" sz="1500" dirty="0"/>
           </a:p>
@@ -10758,7 +10758,7 @@
                 <a:ea typeface="Arial" pitchFamily="34" charset="-122"/>
                 <a:cs typeface="Arial" pitchFamily="34" charset="-120"/>
               </a:rPr>
-              <a:t>Top 500</a:t>
+              <a:t>Top 1,000</a:t>
             </a:r>
             <a:endParaRPr lang="en-US" sz="2400" dirty="0"/>
           </a:p>
@@ -10797,7 +10797,7 @@
                 <a:ea typeface="Arial" pitchFamily="34" charset="-122"/>
                 <a:cs typeface="Arial" pitchFamily="34" charset="-120"/>
               </a:rPr>
-              <a:t>trader by all-time PnL</a:t>
+              <a:t>positions by Datadash score, any wallet</a:t>
             </a:r>
             <a:endParaRPr lang="en-US" sz="1300" dirty="0"/>
           </a:p>
@@ -11427,7 +11427,7 @@
                 <a:ea typeface="Arial" pitchFamily="34" charset="-122"/>
                 <a:cs typeface="Arial" pitchFamily="34" charset="-120"/>
               </a:rPr>
-              <a:t>since a top trader last bought</a:t>
+              <a:t>since the trader last bought</a:t>
             </a:r>
             <a:endParaRPr lang="en-US" sz="1300" dirty="0"/>
           </a:p>
@@ -11637,7 +11637,7 @@
                 <a:ea typeface="Arial" pitchFamily="34" charset="-122"/>
                 <a:cs typeface="Arial" pitchFamily="34" charset="-120"/>
               </a:rPr>
-              <a:t>of top-500 money on the same side, 3+ wallets</a:t>
+              <a:t>of top-500 money on the same side, $10K+</a:t>
             </a:r>
             <a:endParaRPr lang="en-US" sz="1300" dirty="0"/>
           </a:p>
@@ -13804,7 +13804,7 @@
                 <a:ea typeface="Arial" pitchFamily="34" charset="-122"/>
                 <a:cs typeface="Arial" pitchFamily="34" charset="-120"/>
               </a:rPr>
-              <a:t>A top trader must have bought within 7 days</a:t>
+              <a:t>The trader must have bought within 7 days</a:t>
             </a:r>
             <a:endParaRPr lang="en-US" sz="1700" dirty="0"/>
           </a:p>

</xml_diff>

<commit_message>
feat: free A2MCP service through a read-only Datadash MCP proxy
OKX's CLI calls a listed A2MCP endpoint directly and can't send our Datadash
API key, so mcp-proxy/ is a Vercel function that adds the key server-side and
forwards to api.datadash.xyz/mcp. It exposes only get_schema, query_table and
query_lookup (cohort tools are hidden and refused), strips storage expressions
from schema descriptions, caps request size and rate-limits per caller.

The listing's A2MCP entry points at https://okx.datadash.vercel.app/api/mcp.
Signal history now records the market slug and token id. README and deck
describe the free tier as the proxied Datadash MCP.

Co-Authored-By: Arijit <arijitad.uae@gmail.com>
</commit_message>
<xml_diff>
--- a/pitch/Datadash-Smart-Money.pptx
+++ b/pitch/Datadash-Smart-Money.pptx
@@ -14330,7 +14330,7 @@
                 <a:ea typeface="Arial" pitchFamily="34" charset="-122"/>
                 <a:cs typeface="Arial" pitchFamily="34" charset="-120"/>
               </a:rPr>
-              <a:t>Free Datadash tools any agent can call</a:t>
+              <a:t>Datadash's MCP tools, any agent can call</a:t>
             </a:r>
             <a:endParaRPr lang="en-US" sz="1500" dirty="0"/>
           </a:p>
@@ -14351,7 +14351,7 @@
                 <a:ea typeface="Arial" pitchFamily="34" charset="-122"/>
                 <a:cs typeface="Arial" pitchFamily="34" charset="-120"/>
               </a:rPr>
-              <a:t>smart-money-edge, market-read</a:t>
+              <a:t>Smart money, scores, wallets</a:t>
             </a:r>
             <a:endParaRPr lang="en-US" sz="1500" dirty="0"/>
           </a:p>

</xml_diff>

<commit_message>
docs(pitch): reframe the backtest slide on the YES/NO-only re-run
The re-run (615 settled signals, +2.5% ± 3.6% per signal) is roughly
break-even, so the slide says so, charts return by entry price instead of
by time to settle, and points to the live track record as the real test.
The roadmap no longer promises an in-play sports filter.

Co-Authored-By: Arijit <arijitad.uae@gmail.com>
</commit_message>
<xml_diff>
--- a/pitch/Datadash-Smart-Money.pptx
+++ b/pitch/Datadash-Smart-Money.pptx
@@ -689,7 +689,7 @@
           <a:p>
             <a:r>
               <a:rPr lang="en-US" dirty="0"/>
-              <a:t>The backtest showed most historical signals were sports bets settling within hours; a category filter is the first product change to test.</a:t>
+              <a:t>Next is tuning on the live track record: the backtest can't replay the Datadash score or the smart-money check, so real results decide the thresholds.</a:t>
             </a:r>
             <a:endParaRPr lang="en-US" dirty="0"/>
           </a:p>
@@ -1305,7 +1305,7 @@
           <a:p>
             <a:r>
               <a:rPr lang="en-US" dirty="0"/>
-              <a:t>pnpm backtest. As delivered with caps: 3,782 resolved, 64.9% hit rate, +4.4% ± 1.4% per signal, max drawdown $2,327. Before caps: 6,264 resolved, +2.1% ± 1.1%. Entries at 0.10 to 0.30 lost 20.8%.</a:t>
+              <a:t>pnpm backtest, run 2026-09-23 over 180 days, YES/NO markets only. As delivered with caps: 615 resolved, 66.5% hit rate at average entry 0.65, +2.5% ± 3.6% per signal, +$1,548 at $100 each, max drawdown $2,514. Before caps: 681 resolved, +1.5% ± 3.4%. An earlier run that included team-name sports markets looked stronger (+4.4% over 3,782 signals), but OKX's YES/NO format can't carry those. The live filters that matter most, the Datadash score and the smart-money consensus, can't be replayed.</a:t>
             </a:r>
             <a:endParaRPr lang="en-US" dirty="0"/>
           </a:p>
@@ -4942,7 +4942,7 @@
                 <a:ea typeface="Arial" pitchFamily="34" charset="-122"/>
                 <a:cs typeface="Arial" pitchFamily="34" charset="-120"/>
               </a:rPr>
-              <a:t>Category filters, starting with in-play sports</a:t>
+              <a:t>Category filters for subscribers</a:t>
             </a:r>
             <a:endParaRPr lang="en-US" sz="1600" dirty="0"/>
           </a:p>
@@ -12045,7 +12045,7 @@
                 <a:ea typeface="Arial" pitchFamily="34" charset="-122"/>
                 <a:cs typeface="Arial" pitchFamily="34" charset="-120"/>
               </a:rPr>
-              <a:t>180 days replayed: a thin edge, mostly sports.</a:t>
+              <a:t>180 days replayed: roughly break-even.</a:t>
             </a:r>
             <a:endParaRPr lang="en-US" sz="3600" dirty="0"/>
           </a:p>
@@ -12059,8 +12059,8 @@
         </p:nvSpPr>
         <p:spPr>
           <a:xfrm>
-            <a:off x="731520" y="2103120"/>
-            <a:ext cx="5486400" cy="1280160"/>
+            <a:off x="731520" y="2240280"/>
+            <a:ext cx="5486400" cy="1097280"/>
           </a:xfrm>
           <a:prstGeom prst="rect">
             <a:avLst/>
@@ -12076,17 +12076,17 @@
               <a:buNone/>
             </a:pPr>
             <a:r>
-              <a:rPr lang="en-US" sz="8800" b="1" dirty="0">
-                <a:solidFill>
-                  <a:srgbClr val="2EE6A6"/>
-                </a:solidFill>
-                <a:latin typeface="Arial" pitchFamily="34" charset="0"/>
-                <a:ea typeface="Arial" pitchFamily="34" charset="-122"/>
-                <a:cs typeface="Arial" pitchFamily="34" charset="-120"/>
-              </a:rPr>
-              <a:t>+$16.7K</a:t>
-            </a:r>
-            <a:endParaRPr lang="en-US" sz="8800" dirty="0"/>
+              <a:rPr lang="en-US" sz="6400" b="1" dirty="0">
+                <a:solidFill>
+                  <a:srgbClr val="FFFFFF"/>
+                </a:solidFill>
+                <a:latin typeface="Arial" pitchFamily="34" charset="0"/>
+                <a:ea typeface="Arial" pitchFamily="34" charset="-122"/>
+                <a:cs typeface="Arial" pitchFamily="34" charset="-120"/>
+              </a:rPr>
+              <a:t>Break-even</a:t>
+            </a:r>
+            <a:endParaRPr lang="en-US" sz="6400" dirty="0"/>
           </a:p>
         </p:txBody>
       </p:sp>
@@ -12098,8 +12098,8 @@
         </p:nvSpPr>
         <p:spPr>
           <a:xfrm>
-            <a:off x="731520" y="3429000"/>
-            <a:ext cx="5394960" cy="640080"/>
+            <a:off x="731520" y="3383280"/>
+            <a:ext cx="5394960" cy="731520"/>
           </a:xfrm>
           <a:prstGeom prst="rect">
             <a:avLst/>
@@ -12115,7 +12115,7 @@
               <a:buNone/>
             </a:pPr>
             <a:r>
-              <a:rPr lang="en-US" sz="1700" dirty="0">
+              <a:rPr lang="en-US" sz="1600" dirty="0">
                 <a:solidFill>
                   <a:srgbClr val="C9C4EE"/>
                 </a:solidFill>
@@ -12123,9 +12123,9 @@
                 <a:ea typeface="Arial" pitchFamily="34" charset="-122"/>
                 <a:cs typeface="Arial" pitchFamily="34" charset="-120"/>
               </a:rPr>
-              <a:t>backtest, not a promise: 3,782 settled signals at $100 each, March to September 2026</a:t>
-            </a:r>
-            <a:endParaRPr lang="en-US" sz="1700" dirty="0"/>
+              <a:t>+2.5% ± 3.6% per signal over 615 settled signals at $100 each, March to September 2026. Backtest, not a promise.</a:t>
+            </a:r>
+            <a:endParaRPr lang="en-US" sz="1600" dirty="0"/>
           </a:p>
         </p:txBody>
       </p:sp>
@@ -12162,7 +12162,7 @@
                 <a:ea typeface="Arial" pitchFamily="34" charset="-122"/>
                 <a:cs typeface="Arial" pitchFamily="34" charset="-120"/>
               </a:rPr>
-              <a:t>64.9%</a:t>
+              <a:t>66.5%</a:t>
             </a:r>
             <a:endParaRPr lang="en-US" sz="3000" dirty="0"/>
           </a:p>
@@ -12240,7 +12240,7 @@
                 <a:ea typeface="Arial" pitchFamily="34" charset="-122"/>
                 <a:cs typeface="Arial" pitchFamily="34" charset="-120"/>
               </a:rPr>
-              <a:t>+4.4%</a:t>
+              <a:t>0.65</a:t>
             </a:r>
             <a:endParaRPr lang="en-US" sz="3000" dirty="0"/>
           </a:p>
@@ -12279,7 +12279,7 @@
                 <a:ea typeface="Arial" pitchFamily="34" charset="-122"/>
                 <a:cs typeface="Arial" pitchFamily="34" charset="-120"/>
               </a:rPr>
-              <a:t>per signal</a:t>
+              <a:t>average entry</a:t>
             </a:r>
             <a:endParaRPr lang="en-US" sz="1400" dirty="0"/>
           </a:p>
@@ -12318,7 +12318,7 @@
                 <a:ea typeface="Arial" pitchFamily="34" charset="-122"/>
                 <a:cs typeface="Arial" pitchFamily="34" charset="-120"/>
               </a:rPr>
-              <a:t>$2.3K</a:t>
+              <a:t>$2.5K</a:t>
             </a:r>
             <a:endParaRPr lang="en-US" sz="3000" dirty="0"/>
           </a:p>
@@ -12423,7 +12423,7 @@
                 <a:ea typeface="Arial" pitchFamily="34" charset="-122"/>
                 <a:cs typeface="Arial" pitchFamily="34" charset="-120"/>
               </a:rPr>
-              <a:t>Average return by time to settle</a:t>
+              <a:t>Average return by entry price</a:t>
             </a:r>
             <a:endParaRPr lang="en-US" sz="1400" dirty="0"/>
           </a:p>
@@ -12437,7 +12437,7 @@
         </p:nvSpPr>
         <p:spPr>
           <a:xfrm>
-            <a:off x="6720840" y="4663440"/>
+            <a:off x="6720840" y="3703320"/>
             <a:ext cx="4754880" cy="0"/>
           </a:xfrm>
           <a:prstGeom prst="line">
@@ -12460,18 +12460,18 @@
         </p:nvSpPr>
         <p:spPr>
           <a:xfrm>
-            <a:off x="6903720" y="2935224"/>
-            <a:ext cx="548640" cy="1728216"/>
-          </a:xfrm>
-          <a:prstGeom prst="rect">
-            <a:avLst/>
-          </a:prstGeom>
-          <a:solidFill>
-            <a:srgbClr val="2EE6A6"/>
-          </a:solidFill>
-          <a:ln w="12700">
-            <a:solidFill>
-              <a:srgbClr val="2EE6A6"/>
+            <a:off x="7040880" y="3703320"/>
+            <a:ext cx="640080" cy="914400"/>
+          </a:xfrm>
+          <a:prstGeom prst="rect">
+            <a:avLst/>
+          </a:prstGeom>
+          <a:solidFill>
+            <a:srgbClr val="FF6B7A"/>
+          </a:solidFill>
+          <a:ln w="12700">
+            <a:solidFill>
+              <a:srgbClr val="FF6B7A"/>
             </a:solidFill>
             <a:prstDash val="solid"/>
           </a:ln>
@@ -12485,8 +12485,8 @@
         </p:nvSpPr>
         <p:spPr>
           <a:xfrm>
-            <a:off x="6720840" y="2615184"/>
-            <a:ext cx="914400" cy="274320"/>
+            <a:off x="6812280" y="4663440"/>
+            <a:ext cx="1097280" cy="274320"/>
           </a:xfrm>
           <a:prstGeom prst="rect">
             <a:avLst/>
@@ -12504,13 +12504,133 @@
             <a:r>
               <a:rPr lang="en-US" sz="1300" b="1" dirty="0">
                 <a:solidFill>
+                  <a:srgbClr val="FF6B7A"/>
+                </a:solidFill>
+                <a:latin typeface="Arial" pitchFamily="34" charset="0"/>
+                <a:ea typeface="Arial" pitchFamily="34" charset="-122"/>
+                <a:cs typeface="Arial" pitchFamily="34" charset="-120"/>
+              </a:rPr>
+              <a:t>-10.0%</a:t>
+            </a:r>
+            <a:endParaRPr lang="en-US" sz="1300" dirty="0"/>
+          </a:p>
+        </p:txBody>
+      </p:sp>
+      <p:sp>
+        <p:nvSpPr>
+          <p:cNvPr id="21" name="Text 19"/>
+          <p:cNvSpPr txBox="1"/>
+          <p:nvPr/>
+        </p:nvSpPr>
+        <p:spPr>
+          <a:xfrm>
+            <a:off x="6766560" y="5074920"/>
+            <a:ext cx="1188720" cy="457200"/>
+          </a:xfrm>
+          <a:prstGeom prst="rect">
+            <a:avLst/>
+          </a:prstGeom>
+          <a:noFill/>
+          <a:ln/>
+        </p:spPr>
+        <p:txBody>
+          <a:bodyPr wrap="square" lIns="0" tIns="0" rIns="0" bIns="0" rtlCol="0" anchor="ctr"/>
+          <a:lstStyle/>
+          <a:p>
+            <a:pPr algn="ctr" indent="0" marL="0">
+              <a:buNone/>
+            </a:pPr>
+            <a:r>
+              <a:rPr lang="en-US" sz="1200" dirty="0">
+                <a:solidFill>
+                  <a:srgbClr val="C9C4EE"/>
+                </a:solidFill>
+                <a:latin typeface="Arial" pitchFamily="34" charset="0"/>
+                <a:ea typeface="Arial" pitchFamily="34" charset="-122"/>
+                <a:cs typeface="Arial" pitchFamily="34" charset="-120"/>
+              </a:rPr>
+              <a:t>10–30¢</a:t>
+            </a:r>
+            <a:endParaRPr lang="en-US" sz="1200" dirty="0"/>
+          </a:p>
+          <a:p>
+            <a:pPr algn="ctr" indent="0" marL="0">
+              <a:buNone/>
+            </a:pPr>
+            <a:r>
+              <a:rPr lang="en-US" sz="1200" dirty="0">
+                <a:solidFill>
+                  <a:srgbClr val="C9C4EE"/>
+                </a:solidFill>
+                <a:latin typeface="Arial" pitchFamily="34" charset="0"/>
+                <a:ea typeface="Arial" pitchFamily="34" charset="-122"/>
+                <a:cs typeface="Arial" pitchFamily="34" charset="-120"/>
+              </a:rPr>
+              <a:t>44 signals</a:t>
+            </a:r>
+            <a:endParaRPr lang="en-US" sz="1200" dirty="0"/>
+          </a:p>
+        </p:txBody>
+      </p:sp>
+      <p:sp>
+        <p:nvSpPr>
+          <p:cNvPr id="22" name="Shape 20"/>
+          <p:cNvSpPr/>
+          <p:nvPr/>
+        </p:nvSpPr>
+        <p:spPr>
+          <a:xfrm>
+            <a:off x="8183880" y="3438144"/>
+            <a:ext cx="640080" cy="265176"/>
+          </a:xfrm>
+          <a:prstGeom prst="rect">
+            <a:avLst/>
+          </a:prstGeom>
+          <a:solidFill>
+            <a:srgbClr val="7653F6"/>
+          </a:solidFill>
+          <a:ln w="12700">
+            <a:solidFill>
+              <a:srgbClr val="7653F6"/>
+            </a:solidFill>
+            <a:prstDash val="solid"/>
+          </a:ln>
+        </p:spPr>
+      </p:sp>
+      <p:sp>
+        <p:nvSpPr>
+          <p:cNvPr id="23" name="Text 21"/>
+          <p:cNvSpPr txBox="1"/>
+          <p:nvPr/>
+        </p:nvSpPr>
+        <p:spPr>
+          <a:xfrm>
+            <a:off x="7955280" y="3118104"/>
+            <a:ext cx="1097280" cy="274320"/>
+          </a:xfrm>
+          <a:prstGeom prst="rect">
+            <a:avLst/>
+          </a:prstGeom>
+          <a:noFill/>
+          <a:ln/>
+        </p:spPr>
+        <p:txBody>
+          <a:bodyPr wrap="square" lIns="0" tIns="0" rIns="0" bIns="0" rtlCol="0" anchor="ctr"/>
+          <a:lstStyle/>
+          <a:p>
+            <a:pPr algn="ctr" indent="0" marL="0">
+              <a:buNone/>
+            </a:pPr>
+            <a:r>
+              <a:rPr lang="en-US" sz="1300" b="1" dirty="0">
+                <a:solidFill>
                   <a:srgbClr val="FFFFFF"/>
                 </a:solidFill>
                 <a:latin typeface="Arial" pitchFamily="34" charset="0"/>
                 <a:ea typeface="Arial" pitchFamily="34" charset="-122"/>
                 <a:cs typeface="Arial" pitchFamily="34" charset="-120"/>
               </a:rPr>
-              <a:t>+6.3%</a:t>
+              <a:t>+2.9%</a:t>
             </a:r>
             <a:endParaRPr lang="en-US" sz="1300" dirty="0"/>
           </a:p>
@@ -12518,14 +12638,14 @@
       </p:sp>
       <p:sp>
         <p:nvSpPr>
-          <p:cNvPr id="21" name="Text 19"/>
-          <p:cNvSpPr txBox="1"/>
-          <p:nvPr/>
-        </p:nvSpPr>
-        <p:spPr>
-          <a:xfrm>
-            <a:off x="6720840" y="5120640"/>
-            <a:ext cx="914400" cy="274320"/>
+          <p:cNvPr id="24" name="Text 22"/>
+          <p:cNvSpPr txBox="1"/>
+          <p:nvPr/>
+        </p:nvSpPr>
+        <p:spPr>
+          <a:xfrm>
+            <a:off x="7909560" y="5074920"/>
+            <a:ext cx="1188720" cy="457200"/>
           </a:xfrm>
           <a:prstGeom prst="rect">
             <a:avLst/>
@@ -12541,7 +12661,7 @@
               <a:buNone/>
             </a:pPr>
             <a:r>
-              <a:rPr lang="en-US" sz="1300" dirty="0">
+              <a:rPr lang="en-US" sz="1200" dirty="0">
                 <a:solidFill>
                   <a:srgbClr val="C9C4EE"/>
                 </a:solidFill>
@@ -12549,7 +12669,88 @@
                 <a:ea typeface="Arial" pitchFamily="34" charset="-122"/>
                 <a:cs typeface="Arial" pitchFamily="34" charset="-120"/>
               </a:rPr>
-              <a:t>&lt;2h</a:t>
+              <a:t>30–50¢</a:t>
+            </a:r>
+            <a:endParaRPr lang="en-US" sz="1200" dirty="0"/>
+          </a:p>
+          <a:p>
+            <a:pPr algn="ctr" indent="0" marL="0">
+              <a:buNone/>
+            </a:pPr>
+            <a:r>
+              <a:rPr lang="en-US" sz="1200" dirty="0">
+                <a:solidFill>
+                  <a:srgbClr val="C9C4EE"/>
+                </a:solidFill>
+                <a:latin typeface="Arial" pitchFamily="34" charset="0"/>
+                <a:ea typeface="Arial" pitchFamily="34" charset="-122"/>
+                <a:cs typeface="Arial" pitchFamily="34" charset="-120"/>
+              </a:rPr>
+              <a:t>99 signals</a:t>
+            </a:r>
+            <a:endParaRPr lang="en-US" sz="1200" dirty="0"/>
+          </a:p>
+        </p:txBody>
+      </p:sp>
+      <p:sp>
+        <p:nvSpPr>
+          <p:cNvPr id="25" name="Shape 23"/>
+          <p:cNvSpPr/>
+          <p:nvPr/>
+        </p:nvSpPr>
+        <p:spPr>
+          <a:xfrm>
+            <a:off x="9326880" y="3703320"/>
+            <a:ext cx="640080" cy="118872"/>
+          </a:xfrm>
+          <a:prstGeom prst="rect">
+            <a:avLst/>
+          </a:prstGeom>
+          <a:solidFill>
+            <a:srgbClr val="FF6B7A"/>
+          </a:solidFill>
+          <a:ln w="12700">
+            <a:solidFill>
+              <a:srgbClr val="FF6B7A"/>
+            </a:solidFill>
+            <a:prstDash val="solid"/>
+          </a:ln>
+        </p:spPr>
+      </p:sp>
+      <p:sp>
+        <p:nvSpPr>
+          <p:cNvPr id="26" name="Text 24"/>
+          <p:cNvSpPr txBox="1"/>
+          <p:nvPr/>
+        </p:nvSpPr>
+        <p:spPr>
+          <a:xfrm>
+            <a:off x="9098280" y="3867912"/>
+            <a:ext cx="1097280" cy="274320"/>
+          </a:xfrm>
+          <a:prstGeom prst="rect">
+            <a:avLst/>
+          </a:prstGeom>
+          <a:noFill/>
+          <a:ln/>
+        </p:spPr>
+        <p:txBody>
+          <a:bodyPr wrap="square" lIns="0" tIns="0" rIns="0" bIns="0" rtlCol="0" anchor="ctr"/>
+          <a:lstStyle/>
+          <a:p>
+            <a:pPr algn="ctr" indent="0" marL="0">
+              <a:buNone/>
+            </a:pPr>
+            <a:r>
+              <a:rPr lang="en-US" sz="1300" b="1" dirty="0">
+                <a:solidFill>
+                  <a:srgbClr val="FF6B7A"/>
+                </a:solidFill>
+                <a:latin typeface="Arial" pitchFamily="34" charset="0"/>
+                <a:ea typeface="Arial" pitchFamily="34" charset="-122"/>
+                <a:cs typeface="Arial" pitchFamily="34" charset="-120"/>
+              </a:rPr>
+              <a:t>-1.3%</a:t>
             </a:r>
             <a:endParaRPr lang="en-US" sz="1300" dirty="0"/>
           </a:p>
@@ -12557,39 +12758,14 @@
       </p:sp>
       <p:sp>
         <p:nvSpPr>
-          <p:cNvPr id="22" name="Shape 20"/>
-          <p:cNvSpPr/>
-          <p:nvPr/>
-        </p:nvSpPr>
-        <p:spPr>
-          <a:xfrm>
-            <a:off x="7818120" y="4663440"/>
-            <a:ext cx="548640" cy="82296"/>
-          </a:xfrm>
-          <a:prstGeom prst="rect">
-            <a:avLst/>
-          </a:prstGeom>
-          <a:solidFill>
-            <a:srgbClr val="FF6B7A"/>
-          </a:solidFill>
-          <a:ln w="12700">
-            <a:solidFill>
-              <a:srgbClr val="FF6B7A"/>
-            </a:solidFill>
-            <a:prstDash val="solid"/>
-          </a:ln>
-        </p:spPr>
-      </p:sp>
-      <p:sp>
-        <p:nvSpPr>
-          <p:cNvPr id="23" name="Text 21"/>
-          <p:cNvSpPr txBox="1"/>
-          <p:nvPr/>
-        </p:nvSpPr>
-        <p:spPr>
-          <a:xfrm>
-            <a:off x="7635240" y="4736592"/>
-            <a:ext cx="914400" cy="274320"/>
+          <p:cNvPr id="27" name="Text 25"/>
+          <p:cNvSpPr txBox="1"/>
+          <p:nvPr/>
+        </p:nvSpPr>
+        <p:spPr>
+          <a:xfrm>
+            <a:off x="9052560" y="5074920"/>
+            <a:ext cx="1188720" cy="457200"/>
           </a:xfrm>
           <a:prstGeom prst="rect">
             <a:avLst/>
@@ -12605,15 +12781,96 @@
               <a:buNone/>
             </a:pPr>
             <a:r>
+              <a:rPr lang="en-US" sz="1200" dirty="0">
+                <a:solidFill>
+                  <a:srgbClr val="C9C4EE"/>
+                </a:solidFill>
+                <a:latin typeface="Arial" pitchFamily="34" charset="0"/>
+                <a:ea typeface="Arial" pitchFamily="34" charset="-122"/>
+                <a:cs typeface="Arial" pitchFamily="34" charset="-120"/>
+              </a:rPr>
+              <a:t>50–70¢</a:t>
+            </a:r>
+            <a:endParaRPr lang="en-US" sz="1200" dirty="0"/>
+          </a:p>
+          <a:p>
+            <a:pPr algn="ctr" indent="0" marL="0">
+              <a:buNone/>
+            </a:pPr>
+            <a:r>
+              <a:rPr lang="en-US" sz="1200" dirty="0">
+                <a:solidFill>
+                  <a:srgbClr val="C9C4EE"/>
+                </a:solidFill>
+                <a:latin typeface="Arial" pitchFamily="34" charset="0"/>
+                <a:ea typeface="Arial" pitchFamily="34" charset="-122"/>
+                <a:cs typeface="Arial" pitchFamily="34" charset="-120"/>
+              </a:rPr>
+              <a:t>203 signals</a:t>
+            </a:r>
+            <a:endParaRPr lang="en-US" sz="1200" dirty="0"/>
+          </a:p>
+        </p:txBody>
+      </p:sp>
+      <p:sp>
+        <p:nvSpPr>
+          <p:cNvPr id="28" name="Shape 26"/>
+          <p:cNvSpPr/>
+          <p:nvPr/>
+        </p:nvSpPr>
+        <p:spPr>
+          <a:xfrm>
+            <a:off x="10469880" y="3401568"/>
+            <a:ext cx="640080" cy="301752"/>
+          </a:xfrm>
+          <a:prstGeom prst="rect">
+            <a:avLst/>
+          </a:prstGeom>
+          <a:solidFill>
+            <a:srgbClr val="7653F6"/>
+          </a:solidFill>
+          <a:ln w="12700">
+            <a:solidFill>
+              <a:srgbClr val="7653F6"/>
+            </a:solidFill>
+            <a:prstDash val="solid"/>
+          </a:ln>
+        </p:spPr>
+      </p:sp>
+      <p:sp>
+        <p:nvSpPr>
+          <p:cNvPr id="29" name="Text 27"/>
+          <p:cNvSpPr txBox="1"/>
+          <p:nvPr/>
+        </p:nvSpPr>
+        <p:spPr>
+          <a:xfrm>
+            <a:off x="10241280" y="3081528"/>
+            <a:ext cx="1097280" cy="274320"/>
+          </a:xfrm>
+          <a:prstGeom prst="rect">
+            <a:avLst/>
+          </a:prstGeom>
+          <a:noFill/>
+          <a:ln/>
+        </p:spPr>
+        <p:txBody>
+          <a:bodyPr wrap="square" lIns="0" tIns="0" rIns="0" bIns="0" rtlCol="0" anchor="ctr"/>
+          <a:lstStyle/>
+          <a:p>
+            <a:pPr algn="ctr" indent="0" marL="0">
+              <a:buNone/>
+            </a:pPr>
+            <a:r>
               <a:rPr lang="en-US" sz="1300" b="1" dirty="0">
                 <a:solidFill>
-                  <a:srgbClr val="FF6B7A"/>
-                </a:solidFill>
-                <a:latin typeface="Arial" pitchFamily="34" charset="0"/>
-                <a:ea typeface="Arial" pitchFamily="34" charset="-122"/>
-                <a:cs typeface="Arial" pitchFamily="34" charset="-120"/>
-              </a:rPr>
-              <a:t>-0.3%</a:t>
+                  <a:srgbClr val="FFFFFF"/>
+                </a:solidFill>
+                <a:latin typeface="Arial" pitchFamily="34" charset="0"/>
+                <a:ea typeface="Arial" pitchFamily="34" charset="-122"/>
+                <a:cs typeface="Arial" pitchFamily="34" charset="-120"/>
+              </a:rPr>
+              <a:t>+3.3%</a:t>
             </a:r>
             <a:endParaRPr lang="en-US" sz="1300" dirty="0"/>
           </a:p>
@@ -12621,14 +12878,14 @@
       </p:sp>
       <p:sp>
         <p:nvSpPr>
-          <p:cNvPr id="24" name="Text 22"/>
-          <p:cNvSpPr txBox="1"/>
-          <p:nvPr/>
-        </p:nvSpPr>
-        <p:spPr>
-          <a:xfrm>
-            <a:off x="7635240" y="5120640"/>
-            <a:ext cx="914400" cy="274320"/>
+          <p:cNvPr id="30" name="Text 28"/>
+          <p:cNvSpPr txBox="1"/>
+          <p:nvPr/>
+        </p:nvSpPr>
+        <p:spPr>
+          <a:xfrm>
+            <a:off x="10195560" y="5074920"/>
+            <a:ext cx="1188720" cy="457200"/>
           </a:xfrm>
           <a:prstGeom prst="rect">
             <a:avLst/>
@@ -12644,7 +12901,7 @@
               <a:buNone/>
             </a:pPr>
             <a:r>
-              <a:rPr lang="en-US" sz="1300" dirty="0">
+              <a:rPr lang="en-US" sz="1200" dirty="0">
                 <a:solidFill>
                   <a:srgbClr val="C9C4EE"/>
                 </a:solidFill>
@@ -12652,102 +12909,16 @@
                 <a:ea typeface="Arial" pitchFamily="34" charset="-122"/>
                 <a:cs typeface="Arial" pitchFamily="34" charset="-120"/>
               </a:rPr>
-              <a:t>2–6h</a:t>
-            </a:r>
-            <a:endParaRPr lang="en-US" sz="1300" dirty="0"/>
-          </a:p>
-        </p:txBody>
-      </p:sp>
-      <p:sp>
-        <p:nvSpPr>
-          <p:cNvPr id="25" name="Shape 23"/>
-          <p:cNvSpPr/>
-          <p:nvPr/>
-        </p:nvSpPr>
-        <p:spPr>
-          <a:xfrm>
-            <a:off x="8732520" y="4334256"/>
-            <a:ext cx="548640" cy="329184"/>
-          </a:xfrm>
-          <a:prstGeom prst="rect">
-            <a:avLst/>
-          </a:prstGeom>
-          <a:solidFill>
-            <a:srgbClr val="7653F6"/>
-          </a:solidFill>
-          <a:ln w="12700">
-            <a:solidFill>
-              <a:srgbClr val="7653F6"/>
-            </a:solidFill>
-            <a:prstDash val="solid"/>
-          </a:ln>
-        </p:spPr>
-      </p:sp>
-      <p:sp>
-        <p:nvSpPr>
-          <p:cNvPr id="26" name="Text 24"/>
-          <p:cNvSpPr txBox="1"/>
-          <p:nvPr/>
-        </p:nvSpPr>
-        <p:spPr>
-          <a:xfrm>
-            <a:off x="8549640" y="4014216"/>
-            <a:ext cx="914400" cy="274320"/>
-          </a:xfrm>
-          <a:prstGeom prst="rect">
-            <a:avLst/>
-          </a:prstGeom>
-          <a:noFill/>
-          <a:ln/>
-        </p:spPr>
-        <p:txBody>
-          <a:bodyPr wrap="square" lIns="0" tIns="0" rIns="0" bIns="0" rtlCol="0" anchor="ctr"/>
-          <a:lstStyle/>
+              <a:t>70–85¢</a:t>
+            </a:r>
+            <a:endParaRPr lang="en-US" sz="1200" dirty="0"/>
+          </a:p>
           <a:p>
             <a:pPr algn="ctr" indent="0" marL="0">
               <a:buNone/>
             </a:pPr>
             <a:r>
-              <a:rPr lang="en-US" sz="1300" b="1" dirty="0">
-                <a:solidFill>
-                  <a:srgbClr val="FFFFFF"/>
-                </a:solidFill>
-                <a:latin typeface="Arial" pitchFamily="34" charset="0"/>
-                <a:ea typeface="Arial" pitchFamily="34" charset="-122"/>
-                <a:cs typeface="Arial" pitchFamily="34" charset="-120"/>
-              </a:rPr>
-              <a:t>+1.2%</a:t>
-            </a:r>
-            <a:endParaRPr lang="en-US" sz="1300" dirty="0"/>
-          </a:p>
-        </p:txBody>
-      </p:sp>
-      <p:sp>
-        <p:nvSpPr>
-          <p:cNvPr id="27" name="Text 25"/>
-          <p:cNvSpPr txBox="1"/>
-          <p:nvPr/>
-        </p:nvSpPr>
-        <p:spPr>
-          <a:xfrm>
-            <a:off x="8549640" y="5120640"/>
-            <a:ext cx="914400" cy="274320"/>
-          </a:xfrm>
-          <a:prstGeom prst="rect">
-            <a:avLst/>
-          </a:prstGeom>
-          <a:noFill/>
-          <a:ln/>
-        </p:spPr>
-        <p:txBody>
-          <a:bodyPr wrap="square" lIns="0" tIns="0" rIns="0" bIns="0" rtlCol="0" anchor="ctr"/>
-          <a:lstStyle/>
-          <a:p>
-            <a:pPr algn="ctr" indent="0" marL="0">
-              <a:buNone/>
-            </a:pPr>
-            <a:r>
-              <a:rPr lang="en-US" sz="1300" dirty="0">
+              <a:rPr lang="en-US" sz="1200" dirty="0">
                 <a:solidFill>
                   <a:srgbClr val="C9C4EE"/>
                 </a:solidFill>
@@ -12755,221 +12926,15 @@
                 <a:ea typeface="Arial" pitchFamily="34" charset="-122"/>
                 <a:cs typeface="Arial" pitchFamily="34" charset="-120"/>
               </a:rPr>
-              <a:t>6–24h</a:t>
-            </a:r>
-            <a:endParaRPr lang="en-US" sz="1300" dirty="0"/>
-          </a:p>
-        </p:txBody>
-      </p:sp>
-      <p:sp>
-        <p:nvSpPr>
-          <p:cNvPr id="28" name="Shape 26"/>
-          <p:cNvSpPr/>
-          <p:nvPr/>
-        </p:nvSpPr>
-        <p:spPr>
-          <a:xfrm>
-            <a:off x="9646920" y="4087368"/>
-            <a:ext cx="548640" cy="576072"/>
-          </a:xfrm>
-          <a:prstGeom prst="rect">
-            <a:avLst/>
-          </a:prstGeom>
-          <a:solidFill>
-            <a:srgbClr val="7653F6"/>
-          </a:solidFill>
-          <a:ln w="12700">
-            <a:solidFill>
-              <a:srgbClr val="7653F6"/>
-            </a:solidFill>
-            <a:prstDash val="solid"/>
-          </a:ln>
-        </p:spPr>
-      </p:sp>
-      <p:sp>
-        <p:nvSpPr>
-          <p:cNvPr id="29" name="Text 27"/>
-          <p:cNvSpPr txBox="1"/>
-          <p:nvPr/>
-        </p:nvSpPr>
-        <p:spPr>
-          <a:xfrm>
-            <a:off x="9464040" y="3767328"/>
-            <a:ext cx="914400" cy="274320"/>
-          </a:xfrm>
-          <a:prstGeom prst="rect">
-            <a:avLst/>
-          </a:prstGeom>
-          <a:noFill/>
-          <a:ln/>
-        </p:spPr>
-        <p:txBody>
-          <a:bodyPr wrap="square" lIns="0" tIns="0" rIns="0" bIns="0" rtlCol="0" anchor="ctr"/>
-          <a:lstStyle/>
-          <a:p>
-            <a:pPr algn="ctr" indent="0" marL="0">
-              <a:buNone/>
-            </a:pPr>
-            <a:r>
-              <a:rPr lang="en-US" sz="1300" b="1" dirty="0">
-                <a:solidFill>
-                  <a:srgbClr val="FFFFFF"/>
-                </a:solidFill>
-                <a:latin typeface="Arial" pitchFamily="34" charset="0"/>
-                <a:ea typeface="Arial" pitchFamily="34" charset="-122"/>
-                <a:cs typeface="Arial" pitchFamily="34" charset="-120"/>
-              </a:rPr>
-              <a:t>+2.1%</a:t>
-            </a:r>
-            <a:endParaRPr lang="en-US" sz="1300" dirty="0"/>
-          </a:p>
-        </p:txBody>
-      </p:sp>
-      <p:sp>
-        <p:nvSpPr>
-          <p:cNvPr id="30" name="Text 28"/>
-          <p:cNvSpPr txBox="1"/>
-          <p:nvPr/>
-        </p:nvSpPr>
-        <p:spPr>
-          <a:xfrm>
-            <a:off x="9464040" y="5120640"/>
-            <a:ext cx="914400" cy="274320"/>
-          </a:xfrm>
-          <a:prstGeom prst="rect">
-            <a:avLst/>
-          </a:prstGeom>
-          <a:noFill/>
-          <a:ln/>
-        </p:spPr>
-        <p:txBody>
-          <a:bodyPr wrap="square" lIns="0" tIns="0" rIns="0" bIns="0" rtlCol="0" anchor="ctr"/>
-          <a:lstStyle/>
-          <a:p>
-            <a:pPr algn="ctr" indent="0" marL="0">
-              <a:buNone/>
-            </a:pPr>
-            <a:r>
-              <a:rPr lang="en-US" sz="1300" dirty="0">
-                <a:solidFill>
-                  <a:srgbClr val="C9C4EE"/>
-                </a:solidFill>
-                <a:latin typeface="Arial" pitchFamily="34" charset="0"/>
-                <a:ea typeface="Arial" pitchFamily="34" charset="-122"/>
-                <a:cs typeface="Arial" pitchFamily="34" charset="-120"/>
-              </a:rPr>
-              <a:t>1–7d</a:t>
-            </a:r>
-            <a:endParaRPr lang="en-US" sz="1300" dirty="0"/>
-          </a:p>
-        </p:txBody>
-      </p:sp>
-      <p:sp>
-        <p:nvSpPr>
-          <p:cNvPr id="31" name="Shape 29"/>
-          <p:cNvSpPr/>
-          <p:nvPr/>
-        </p:nvSpPr>
-        <p:spPr>
-          <a:xfrm>
-            <a:off x="10561320" y="3813048"/>
-            <a:ext cx="548640" cy="850392"/>
-          </a:xfrm>
-          <a:prstGeom prst="rect">
-            <a:avLst/>
-          </a:prstGeom>
-          <a:solidFill>
-            <a:srgbClr val="7653F6"/>
-          </a:solidFill>
-          <a:ln w="12700">
-            <a:solidFill>
-              <a:srgbClr val="7653F6"/>
-            </a:solidFill>
-            <a:prstDash val="solid"/>
-          </a:ln>
-        </p:spPr>
-      </p:sp>
-      <p:sp>
-        <p:nvSpPr>
-          <p:cNvPr id="32" name="Text 30"/>
-          <p:cNvSpPr txBox="1"/>
-          <p:nvPr/>
-        </p:nvSpPr>
-        <p:spPr>
-          <a:xfrm>
-            <a:off x="10378440" y="3493008"/>
-            <a:ext cx="914400" cy="274320"/>
-          </a:xfrm>
-          <a:prstGeom prst="rect">
-            <a:avLst/>
-          </a:prstGeom>
-          <a:noFill/>
-          <a:ln/>
-        </p:spPr>
-        <p:txBody>
-          <a:bodyPr wrap="square" lIns="0" tIns="0" rIns="0" bIns="0" rtlCol="0" anchor="ctr"/>
-          <a:lstStyle/>
-          <a:p>
-            <a:pPr algn="ctr" indent="0" marL="0">
-              <a:buNone/>
-            </a:pPr>
-            <a:r>
-              <a:rPr lang="en-US" sz="1300" b="1" dirty="0">
-                <a:solidFill>
-                  <a:srgbClr val="FFFFFF"/>
-                </a:solidFill>
-                <a:latin typeface="Arial" pitchFamily="34" charset="0"/>
-                <a:ea typeface="Arial" pitchFamily="34" charset="-122"/>
-                <a:cs typeface="Arial" pitchFamily="34" charset="-120"/>
-              </a:rPr>
-              <a:t>+3.1%</a:t>
-            </a:r>
-            <a:endParaRPr lang="en-US" sz="1300" dirty="0"/>
-          </a:p>
-        </p:txBody>
-      </p:sp>
-      <p:sp>
-        <p:nvSpPr>
-          <p:cNvPr id="33" name="Text 31"/>
-          <p:cNvSpPr txBox="1"/>
-          <p:nvPr/>
-        </p:nvSpPr>
-        <p:spPr>
-          <a:xfrm>
-            <a:off x="10378440" y="5120640"/>
-            <a:ext cx="914400" cy="274320"/>
-          </a:xfrm>
-          <a:prstGeom prst="rect">
-            <a:avLst/>
-          </a:prstGeom>
-          <a:noFill/>
-          <a:ln/>
-        </p:spPr>
-        <p:txBody>
-          <a:bodyPr wrap="square" lIns="0" tIns="0" rIns="0" bIns="0" rtlCol="0" anchor="ctr"/>
-          <a:lstStyle/>
-          <a:p>
-            <a:pPr algn="ctr" indent="0" marL="0">
-              <a:buNone/>
-            </a:pPr>
-            <a:r>
-              <a:rPr lang="en-US" sz="1300" dirty="0">
-                <a:solidFill>
-                  <a:srgbClr val="C9C4EE"/>
-                </a:solidFill>
-                <a:latin typeface="Arial" pitchFamily="34" charset="0"/>
-                <a:ea typeface="Arial" pitchFamily="34" charset="-122"/>
-                <a:cs typeface="Arial" pitchFamily="34" charset="-120"/>
-              </a:rPr>
-              <a:t>&gt;7d</a:t>
-            </a:r>
-            <a:endParaRPr lang="en-US" sz="1300" dirty="0"/>
-          </a:p>
-        </p:txBody>
-      </p:sp>
-      <p:sp>
-        <p:nvSpPr>
-          <p:cNvPr id="34" name="Text 32"/>
+              <a:t>304 signals</a:t>
+            </a:r>
+            <a:endParaRPr lang="en-US" sz="1200" dirty="0"/>
+          </a:p>
+        </p:txBody>
+      </p:sp>
+      <p:sp>
+        <p:nvSpPr>
+          <p:cNvPr id="31" name="Text 29"/>
           <p:cNvSpPr txBox="1"/>
           <p:nvPr/>
         </p:nvSpPr>
@@ -13000,7 +12965,7 @@
                 <a:ea typeface="Arial" pitchFamily="34" charset="-122"/>
                 <a:cs typeface="Arial" pitchFamily="34" charset="-120"/>
               </a:rPr>
-              <a:t>Honest limits: wallet ranks are today's (look-ahead bias) · 93% sports, most settling within hours · the score and smart-money check can't be replayed · signals taking a day or more: +2.4% ± 2.9%. The live track record is the real test.</a:t>
+              <a:t>What it can't test: the Datadash score and the smart-money check only exist for today's holdings, and wallet ranks are today's. So every live signal is scored as its market settles: the track record is the real test.</a:t>
             </a:r>
             <a:endParaRPr lang="en-US" sz="1400" dirty="0"/>
           </a:p>

</xml_diff>